<commit_message>
Stat to make Tour Guide JP
</commit_message>
<xml_diff>
--- a/Documents/Original/FlexChroma_Tour_Guide_EN.pptx
+++ b/Documents/Original/FlexChroma_Tour_Guide_EN.pptx
@@ -249,7 +249,7 @@
           <a:p>
             <a:fld id="{71132294-360C-4425-B294-91EF6E97A591}" type="datetimeFigureOut">
               <a:rPr kumimoji="1" lang="ja-JP" altLang="en-US" smtClean="0"/>
-              <a:t>2026/7/22</a:t>
+              <a:t>2026/7/23</a:t>
             </a:fld>
             <a:endParaRPr kumimoji="1" lang="ja-JP" altLang="en-US"/>
           </a:p>
@@ -451,7 +451,7 @@
           <a:p>
             <a:fld id="{71132294-360C-4425-B294-91EF6E97A591}" type="datetimeFigureOut">
               <a:rPr kumimoji="1" lang="ja-JP" altLang="en-US" smtClean="0"/>
-              <a:t>2026/7/22</a:t>
+              <a:t>2026/7/23</a:t>
             </a:fld>
             <a:endParaRPr kumimoji="1" lang="ja-JP" altLang="en-US"/>
           </a:p>
@@ -663,7 +663,7 @@
           <a:p>
             <a:fld id="{71132294-360C-4425-B294-91EF6E97A591}" type="datetimeFigureOut">
               <a:rPr kumimoji="1" lang="ja-JP" altLang="en-US" smtClean="0"/>
-              <a:t>2026/7/22</a:t>
+              <a:t>2026/7/23</a:t>
             </a:fld>
             <a:endParaRPr kumimoji="1" lang="ja-JP" altLang="en-US"/>
           </a:p>
@@ -865,7 +865,7 @@
           <a:p>
             <a:fld id="{71132294-360C-4425-B294-91EF6E97A591}" type="datetimeFigureOut">
               <a:rPr kumimoji="1" lang="ja-JP" altLang="en-US" smtClean="0"/>
-              <a:t>2026/7/22</a:t>
+              <a:t>2026/7/23</a:t>
             </a:fld>
             <a:endParaRPr kumimoji="1" lang="ja-JP" altLang="en-US"/>
           </a:p>
@@ -1111,7 +1111,7 @@
           <a:p>
             <a:fld id="{71132294-360C-4425-B294-91EF6E97A591}" type="datetimeFigureOut">
               <a:rPr kumimoji="1" lang="ja-JP" altLang="en-US" smtClean="0"/>
-              <a:t>2026/7/22</a:t>
+              <a:t>2026/7/23</a:t>
             </a:fld>
             <a:endParaRPr kumimoji="1" lang="ja-JP" altLang="en-US"/>
           </a:p>
@@ -1407,7 +1407,7 @@
           <a:p>
             <a:fld id="{71132294-360C-4425-B294-91EF6E97A591}" type="datetimeFigureOut">
               <a:rPr kumimoji="1" lang="ja-JP" altLang="en-US" smtClean="0"/>
-              <a:t>2026/7/22</a:t>
+              <a:t>2026/7/23</a:t>
             </a:fld>
             <a:endParaRPr kumimoji="1" lang="ja-JP" altLang="en-US"/>
           </a:p>
@@ -1838,7 +1838,7 @@
           <a:p>
             <a:fld id="{71132294-360C-4425-B294-91EF6E97A591}" type="datetimeFigureOut">
               <a:rPr kumimoji="1" lang="ja-JP" altLang="en-US" smtClean="0"/>
-              <a:t>2026/7/22</a:t>
+              <a:t>2026/7/23</a:t>
             </a:fld>
             <a:endParaRPr kumimoji="1" lang="ja-JP" altLang="en-US"/>
           </a:p>
@@ -1956,7 +1956,7 @@
           <a:p>
             <a:fld id="{71132294-360C-4425-B294-91EF6E97A591}" type="datetimeFigureOut">
               <a:rPr kumimoji="1" lang="ja-JP" altLang="en-US" smtClean="0"/>
-              <a:t>2026/7/22</a:t>
+              <a:t>2026/7/23</a:t>
             </a:fld>
             <a:endParaRPr kumimoji="1" lang="ja-JP" altLang="en-US"/>
           </a:p>
@@ -2051,7 +2051,7 @@
           <a:p>
             <a:fld id="{71132294-360C-4425-B294-91EF6E97A591}" type="datetimeFigureOut">
               <a:rPr kumimoji="1" lang="ja-JP" altLang="en-US" smtClean="0"/>
-              <a:t>2026/7/22</a:t>
+              <a:t>2026/7/23</a:t>
             </a:fld>
             <a:endParaRPr kumimoji="1" lang="ja-JP" altLang="en-US"/>
           </a:p>
@@ -2360,7 +2360,7 @@
           <a:p>
             <a:fld id="{71132294-360C-4425-B294-91EF6E97A591}" type="datetimeFigureOut">
               <a:rPr kumimoji="1" lang="ja-JP" altLang="en-US" smtClean="0"/>
-              <a:t>2026/7/22</a:t>
+              <a:t>2026/7/23</a:t>
             </a:fld>
             <a:endParaRPr kumimoji="1" lang="ja-JP" altLang="en-US"/>
           </a:p>
@@ -2617,7 +2617,7 @@
           <a:p>
             <a:fld id="{71132294-360C-4425-B294-91EF6E97A591}" type="datetimeFigureOut">
               <a:rPr kumimoji="1" lang="ja-JP" altLang="en-US" smtClean="0"/>
-              <a:t>2026/7/22</a:t>
+              <a:t>2026/7/23</a:t>
             </a:fld>
             <a:endParaRPr kumimoji="1" lang="ja-JP" altLang="en-US"/>
           </a:p>
@@ -2862,7 +2862,7 @@
           <a:p>
             <a:fld id="{71132294-360C-4425-B294-91EF6E97A591}" type="datetimeFigureOut">
               <a:rPr kumimoji="1" lang="ja-JP" altLang="en-US" smtClean="0"/>
-              <a:t>2026/7/22</a:t>
+              <a:t>2026/7/23</a:t>
             </a:fld>
             <a:endParaRPr kumimoji="1" lang="ja-JP" altLang="en-US"/>
           </a:p>
@@ -5177,7 +5177,22 @@
                 <a:latin typeface="IBM Plex Sans JP" panose="020B0503050203000203" pitchFamily="50" charset="-128"/>
                 <a:ea typeface="IBM Plex Sans JP" panose="020B0503050203000203" pitchFamily="50" charset="-128"/>
               </a:rPr>
-              <a:t>- Let's Explore FlexChroma's Models -</a:t>
+              <a:t>- Let's Explore </a:t>
+            </a:r>
+            <a:r>
+              <a:rPr lang="en-US" altLang="ja-JP" sz="1600" dirty="0">
+                <a:latin typeface="Segoe UI Semibold" panose="020B0702040204020203" pitchFamily="34" charset="0"/>
+                <a:ea typeface="IBM Plex Sans JP" panose="020B0503050203000203" pitchFamily="50" charset="-128"/>
+                <a:cs typeface="Segoe UI Semibold" panose="020B0702040204020203" pitchFamily="34" charset="0"/>
+              </a:rPr>
+              <a:t>FlexChroma</a:t>
+            </a:r>
+            <a:r>
+              <a:rPr lang="en-US" altLang="ja-JP" sz="1600" dirty="0">
+                <a:latin typeface="IBM Plex Sans JP" panose="020B0503050203000203" pitchFamily="50" charset="-128"/>
+                <a:ea typeface="IBM Plex Sans JP" panose="020B0503050203000203" pitchFamily="50" charset="-128"/>
+              </a:rPr>
+              <a:t>'s Models -</a:t>
             </a:r>
             <a:endParaRPr kumimoji="1" lang="ja-JP" altLang="en-US" sz="1600" dirty="0">
               <a:latin typeface="IBM Plex Sans JP" panose="020B0503050203000203" pitchFamily="50" charset="-128"/>
@@ -7925,7 +7940,22 @@
                 <a:latin typeface="IBM Plex Sans JP" panose="020B0503050203000203" pitchFamily="50" charset="-128"/>
                 <a:ea typeface="IBM Plex Sans JP" panose="020B0503050203000203" pitchFamily="50" charset="-128"/>
               </a:rPr>
-              <a:t>- Let's Explore FlexChroma's Models -</a:t>
+              <a:t>- Let's Explore </a:t>
+            </a:r>
+            <a:r>
+              <a:rPr lang="en-US" altLang="ja-JP" sz="1600" dirty="0">
+                <a:latin typeface="Segoe UI Semibold" panose="020B0702040204020203" pitchFamily="34" charset="0"/>
+                <a:ea typeface="IBM Plex Sans JP" panose="020B0503050203000203" pitchFamily="50" charset="-128"/>
+                <a:cs typeface="Segoe UI Semibold" panose="020B0702040204020203" pitchFamily="34" charset="0"/>
+              </a:rPr>
+              <a:t>FlexChroma</a:t>
+            </a:r>
+            <a:r>
+              <a:rPr lang="en-US" altLang="ja-JP" sz="1600" dirty="0">
+                <a:latin typeface="IBM Plex Sans JP" panose="020B0503050203000203" pitchFamily="50" charset="-128"/>
+                <a:ea typeface="IBM Plex Sans JP" panose="020B0503050203000203" pitchFamily="50" charset="-128"/>
+              </a:rPr>
+              <a:t>'s Models -</a:t>
             </a:r>
             <a:endParaRPr kumimoji="1" lang="ja-JP" altLang="en-US" sz="1600" dirty="0">
               <a:latin typeface="IBM Plex Sans JP" panose="020B0503050203000203" pitchFamily="50" charset="-128"/>

</xml_diff>

<commit_message>
Update Tour guide and add tour guide section to translation table
</commit_message>
<xml_diff>
--- a/Documents/Original/FlexChroma_Tour_Guide_EN.pptx
+++ b/Documents/Original/FlexChroma_Tour_Guide_EN.pptx
@@ -12,7 +12,8 @@
     <p:sldId id="265" r:id="rId6"/>
     <p:sldId id="263" r:id="rId7"/>
     <p:sldId id="264" r:id="rId8"/>
-    <p:sldId id="262" r:id="rId9"/>
+    <p:sldId id="266" r:id="rId9"/>
+    <p:sldId id="267" r:id="rId10"/>
   </p:sldIdLst>
   <p:sldSz cx="6858000" cy="9144000" type="screen4x3"/>
   <p:notesSz cx="7104063" cy="10234613"/>
@@ -5217,7 +5218,7 @@
         <p:spPr>
           <a:xfrm>
             <a:off x="2381276" y="1883364"/>
-            <a:ext cx="1952779" cy="307777"/>
+            <a:ext cx="1790875" cy="307777"/>
           </a:xfrm>
           <a:prstGeom prst="rect">
             <a:avLst/>
@@ -5235,7 +5236,7 @@
                 <a:latin typeface="IBM Plex Sans JP" panose="020B0503050203000203" pitchFamily="50" charset="-128"/>
                 <a:ea typeface="IBM Plex Sans JP" panose="020B0503050203000203" pitchFamily="50" charset="-128"/>
               </a:rPr>
-              <a:t>Ver.1.10  2026.7.22</a:t>
+              <a:t>Ver.1.11  2026.8.8</a:t>
             </a:r>
             <a:endParaRPr kumimoji="1" lang="ja-JP" altLang="en-US" sz="1400" dirty="0">
               <a:latin typeface="IBM Plex Sans JP" panose="020B0503050203000203" pitchFamily="50" charset="-128"/>
@@ -7913,7 +7914,7 @@
                 <a:latin typeface="IBM Plex Sans JP" panose="020B0503050203000203" pitchFamily="50" charset="-128"/>
                 <a:ea typeface="IBM Plex Sans JP" panose="020B0503050203000203" pitchFamily="50" charset="-128"/>
               </a:rPr>
-              <a:t>Ver.1.10  2026-07-02  Revisions for Integrated Design</a:t>
+              <a:t>Ver.1.10  2026-07-22  Revisions for Integrated Design</a:t>
             </a:r>
           </a:p>
           <a:p>
@@ -8612,7 +8613,7 @@
         <p:spPr>
           <a:xfrm>
             <a:off x="2381276" y="1883364"/>
-            <a:ext cx="1952779" cy="307777"/>
+            <a:ext cx="1790875" cy="307777"/>
           </a:xfrm>
           <a:prstGeom prst="rect">
             <a:avLst/>
@@ -8630,7 +8631,7 @@
                 <a:latin typeface="IBM Plex Sans JP" panose="020B0503050203000203" pitchFamily="50" charset="-128"/>
                 <a:ea typeface="IBM Plex Sans JP" panose="020B0503050203000203" pitchFamily="50" charset="-128"/>
               </a:rPr>
-              <a:t>Ver.1.10  2026.7.22</a:t>
+              <a:t>Ver.1.11  2026.8.8</a:t>
             </a:r>
             <a:endParaRPr kumimoji="1" lang="ja-JP" altLang="en-US" sz="1400" dirty="0">
               <a:latin typeface="IBM Plex Sans JP" panose="020B0503050203000203" pitchFamily="50" charset="-128"/>
@@ -9897,7 +9898,7 @@
         <p:cNvPr id="1" name="">
           <a:extLst>
             <a:ext uri="{FF2B5EF4-FFF2-40B4-BE49-F238E27FC236}">
-              <a16:creationId xmlns:a16="http://schemas.microsoft.com/office/drawing/2014/main" id="{3D99E812-8D39-99F5-1D23-0E1A450CC131}"/>
+              <a16:creationId xmlns:a16="http://schemas.microsoft.com/office/drawing/2014/main" id="{3F39D162-0972-E73B-EA5B-12D928783FAF}"/>
             </a:ext>
           </a:extLst>
         </p:cNvPr>
@@ -9914,10 +9915,10 @@
       </p:grpSpPr>
       <p:sp>
         <p:nvSpPr>
-          <p:cNvPr id="3" name="正方形/長方形 2">
+          <p:cNvPr id="30" name="正方形/長方形 29">
             <a:extLst>
               <a:ext uri="{FF2B5EF4-FFF2-40B4-BE49-F238E27FC236}">
-                <a16:creationId xmlns:a16="http://schemas.microsoft.com/office/drawing/2014/main" id="{6D89B353-9D95-712D-2512-32F299577803}"/>
+                <a16:creationId xmlns:a16="http://schemas.microsoft.com/office/drawing/2014/main" id="{41C40E49-5FA1-E53B-CA28-AD02E4FA19E1}"/>
               </a:ext>
             </a:extLst>
           </p:cNvPr>
@@ -9926,7 +9927,7 @@
         </p:nvSpPr>
         <p:spPr>
           <a:xfrm>
-            <a:off x="33951" y="45268"/>
+            <a:off x="51086" y="45268"/>
             <a:ext cx="6790099" cy="9053465"/>
           </a:xfrm>
           <a:prstGeom prst="rect">
@@ -9977,10 +9978,10 @@
       </p:sp>
       <p:sp>
         <p:nvSpPr>
-          <p:cNvPr id="7" name="フリーフォーム: 図形 6">
+          <p:cNvPr id="18" name="フリーフォーム: 図形 17">
             <a:extLst>
               <a:ext uri="{FF2B5EF4-FFF2-40B4-BE49-F238E27FC236}">
-                <a16:creationId xmlns:a16="http://schemas.microsoft.com/office/drawing/2014/main" id="{EBB0D2A0-3A2E-56E5-5FE5-78980A9D36F4}"/>
+                <a16:creationId xmlns:a16="http://schemas.microsoft.com/office/drawing/2014/main" id="{9909E367-C232-F8D9-9E16-57CEC232B45C}"/>
               </a:ext>
             </a:extLst>
           </p:cNvPr>
@@ -9989,244 +9990,195 @@
         </p:nvSpPr>
         <p:spPr>
           <a:xfrm>
-            <a:off x="-3234" y="0"/>
-            <a:ext cx="6861231" cy="9144000"/>
+            <a:off x="17051" y="5531"/>
+            <a:ext cx="6858000" cy="9144000"/>
           </a:xfrm>
           <a:custGeom>
             <a:avLst/>
             <a:gdLst>
-              <a:gd name="connsiteX0" fmla="*/ 3739836 w 6861231"/>
-              <a:gd name="connsiteY0" fmla="*/ 8661917 h 9144000"/>
-              <a:gd name="connsiteX1" fmla="*/ 3739836 w 6861231"/>
-              <a:gd name="connsiteY1" fmla="*/ 8715917 h 9144000"/>
-              <a:gd name="connsiteX2" fmla="*/ 6333058 w 6861231"/>
-              <a:gd name="connsiteY2" fmla="*/ 8715917 h 9144000"/>
-              <a:gd name="connsiteX3" fmla="*/ 6333058 w 6861231"/>
-              <a:gd name="connsiteY3" fmla="*/ 8661917 h 9144000"/>
-              <a:gd name="connsiteX4" fmla="*/ 558032 w 6861231"/>
-              <a:gd name="connsiteY4" fmla="*/ 8661917 h 9144000"/>
-              <a:gd name="connsiteX5" fmla="*/ 558032 w 6861231"/>
-              <a:gd name="connsiteY5" fmla="*/ 8715917 h 9144000"/>
-              <a:gd name="connsiteX6" fmla="*/ 3151253 w 6861231"/>
-              <a:gd name="connsiteY6" fmla="*/ 8715917 h 9144000"/>
-              <a:gd name="connsiteX7" fmla="*/ 3151253 w 6861231"/>
-              <a:gd name="connsiteY7" fmla="*/ 8661917 h 9144000"/>
-              <a:gd name="connsiteX8" fmla="*/ 651915 w 6861231"/>
-              <a:gd name="connsiteY8" fmla="*/ 7301051 h 9144000"/>
-              <a:gd name="connsiteX9" fmla="*/ 549580 w 6861231"/>
-              <a:gd name="connsiteY9" fmla="*/ 7403386 h 9144000"/>
-              <a:gd name="connsiteX10" fmla="*/ 651915 w 6861231"/>
-              <a:gd name="connsiteY10" fmla="*/ 7505721 h 9144000"/>
-              <a:gd name="connsiteX11" fmla="*/ 754250 w 6861231"/>
-              <a:gd name="connsiteY11" fmla="*/ 7403386 h 9144000"/>
-              <a:gd name="connsiteX12" fmla="*/ 651915 w 6861231"/>
-              <a:gd name="connsiteY12" fmla="*/ 7301051 h 9144000"/>
-              <a:gd name="connsiteX13" fmla="*/ 672058 w 6861231"/>
-              <a:gd name="connsiteY13" fmla="*/ 677902 h 9144000"/>
-              <a:gd name="connsiteX14" fmla="*/ 569674 w 6861231"/>
-              <a:gd name="connsiteY14" fmla="*/ 780237 h 9144000"/>
-              <a:gd name="connsiteX15" fmla="*/ 672058 w 6861231"/>
-              <a:gd name="connsiteY15" fmla="*/ 882572 h 9144000"/>
-              <a:gd name="connsiteX16" fmla="*/ 774441 w 6861231"/>
-              <a:gd name="connsiteY16" fmla="*/ 780237 h 9144000"/>
-              <a:gd name="connsiteX17" fmla="*/ 672058 w 6861231"/>
-              <a:gd name="connsiteY17" fmla="*/ 677902 h 9144000"/>
-              <a:gd name="connsiteX18" fmla="*/ 558031 w 6861231"/>
-              <a:gd name="connsiteY18" fmla="*/ 452468 h 9144000"/>
-              <a:gd name="connsiteX19" fmla="*/ 558031 w 6861231"/>
-              <a:gd name="connsiteY19" fmla="*/ 506468 h 9144000"/>
-              <a:gd name="connsiteX20" fmla="*/ 6316936 w 6861231"/>
-              <a:gd name="connsiteY20" fmla="*/ 506468 h 9144000"/>
-              <a:gd name="connsiteX21" fmla="*/ 6316936 w 6861231"/>
-              <a:gd name="connsiteY21" fmla="*/ 452468 h 9144000"/>
-              <a:gd name="connsiteX22" fmla="*/ 0 w 6861231"/>
-              <a:gd name="connsiteY22" fmla="*/ 0 h 9144000"/>
-              <a:gd name="connsiteX23" fmla="*/ 6861231 w 6861231"/>
-              <a:gd name="connsiteY23" fmla="*/ 0 h 9144000"/>
-              <a:gd name="connsiteX24" fmla="*/ 6861231 w 6861231"/>
-              <a:gd name="connsiteY24" fmla="*/ 9144000 h 9144000"/>
-              <a:gd name="connsiteX25" fmla="*/ 0 w 6861231"/>
-              <a:gd name="connsiteY25" fmla="*/ 9144000 h 9144000"/>
+              <a:gd name="csX0" fmla="*/ 3717793 w 6858000"/>
+              <a:gd name="csY0" fmla="*/ 8656386 h 9144000"/>
+              <a:gd name="csX1" fmla="*/ 3717793 w 6858000"/>
+              <a:gd name="csY1" fmla="*/ 8710386 h 9144000"/>
+              <a:gd name="csX2" fmla="*/ 6309793 w 6858000"/>
+              <a:gd name="csY2" fmla="*/ 8710386 h 9144000"/>
+              <a:gd name="csX3" fmla="*/ 6309793 w 6858000"/>
+              <a:gd name="csY3" fmla="*/ 8656386 h 9144000"/>
+              <a:gd name="csX4" fmla="*/ 537487 w 6858000"/>
+              <a:gd name="csY4" fmla="*/ 8656386 h 9144000"/>
+              <a:gd name="csX5" fmla="*/ 537487 w 6858000"/>
+              <a:gd name="csY5" fmla="*/ 8710386 h 9144000"/>
+              <a:gd name="csX6" fmla="*/ 3129487 w 6858000"/>
+              <a:gd name="csY6" fmla="*/ 8710386 h 9144000"/>
+              <a:gd name="csX7" fmla="*/ 3129487 w 6858000"/>
+              <a:gd name="csY7" fmla="*/ 8656386 h 9144000"/>
+              <a:gd name="csX8" fmla="*/ 651459 w 6858000"/>
+              <a:gd name="csY8" fmla="*/ 672371 h 9144000"/>
+              <a:gd name="csX9" fmla="*/ 549124 w 6858000"/>
+              <a:gd name="csY9" fmla="*/ 774706 h 9144000"/>
+              <a:gd name="csX10" fmla="*/ 651459 w 6858000"/>
+              <a:gd name="csY10" fmla="*/ 877041 h 9144000"/>
+              <a:gd name="csX11" fmla="*/ 753794 w 6858000"/>
+              <a:gd name="csY11" fmla="*/ 774706 h 9144000"/>
+              <a:gd name="csX12" fmla="*/ 651459 w 6858000"/>
+              <a:gd name="csY12" fmla="*/ 672371 h 9144000"/>
+              <a:gd name="csX13" fmla="*/ 537486 w 6858000"/>
+              <a:gd name="csY13" fmla="*/ 446937 h 9144000"/>
+              <a:gd name="csX14" fmla="*/ 537486 w 6858000"/>
+              <a:gd name="csY14" fmla="*/ 500937 h 9144000"/>
+              <a:gd name="csX15" fmla="*/ 6293679 w 6858000"/>
+              <a:gd name="csY15" fmla="*/ 500937 h 9144000"/>
+              <a:gd name="csX16" fmla="*/ 6293679 w 6858000"/>
+              <a:gd name="csY16" fmla="*/ 446937 h 9144000"/>
+              <a:gd name="csX17" fmla="*/ 0 w 6858000"/>
+              <a:gd name="csY17" fmla="*/ 0 h 9144000"/>
+              <a:gd name="csX18" fmla="*/ 6858000 w 6858000"/>
+              <a:gd name="csY18" fmla="*/ 0 h 9144000"/>
+              <a:gd name="csX19" fmla="*/ 6858000 w 6858000"/>
+              <a:gd name="csY19" fmla="*/ 9144000 h 9144000"/>
+              <a:gd name="csX20" fmla="*/ 0 w 6858000"/>
+              <a:gd name="csY20" fmla="*/ 9144000 h 9144000"/>
             </a:gdLst>
             <a:ahLst/>
             <a:cxnLst>
               <a:cxn ang="0">
-                <a:pos x="connsiteX0" y="connsiteY0"/>
+                <a:pos x="csX0" y="csY0"/>
               </a:cxn>
               <a:cxn ang="0">
-                <a:pos x="connsiteX1" y="connsiteY1"/>
+                <a:pos x="csX1" y="csY1"/>
               </a:cxn>
               <a:cxn ang="0">
-                <a:pos x="connsiteX2" y="connsiteY2"/>
+                <a:pos x="csX2" y="csY2"/>
               </a:cxn>
               <a:cxn ang="0">
-                <a:pos x="connsiteX3" y="connsiteY3"/>
+                <a:pos x="csX3" y="csY3"/>
               </a:cxn>
               <a:cxn ang="0">
-                <a:pos x="connsiteX4" y="connsiteY4"/>
+                <a:pos x="csX4" y="csY4"/>
               </a:cxn>
               <a:cxn ang="0">
-                <a:pos x="connsiteX5" y="connsiteY5"/>
+                <a:pos x="csX5" y="csY5"/>
               </a:cxn>
               <a:cxn ang="0">
-                <a:pos x="connsiteX6" y="connsiteY6"/>
+                <a:pos x="csX6" y="csY6"/>
               </a:cxn>
               <a:cxn ang="0">
-                <a:pos x="connsiteX7" y="connsiteY7"/>
+                <a:pos x="csX7" y="csY7"/>
               </a:cxn>
               <a:cxn ang="0">
-                <a:pos x="connsiteX8" y="connsiteY8"/>
+                <a:pos x="csX8" y="csY8"/>
               </a:cxn>
               <a:cxn ang="0">
-                <a:pos x="connsiteX9" y="connsiteY9"/>
+                <a:pos x="csX9" y="csY9"/>
               </a:cxn>
               <a:cxn ang="0">
-                <a:pos x="connsiteX10" y="connsiteY10"/>
+                <a:pos x="csX10" y="csY10"/>
               </a:cxn>
               <a:cxn ang="0">
-                <a:pos x="connsiteX11" y="connsiteY11"/>
+                <a:pos x="csX11" y="csY11"/>
               </a:cxn>
               <a:cxn ang="0">
-                <a:pos x="connsiteX12" y="connsiteY12"/>
+                <a:pos x="csX12" y="csY12"/>
               </a:cxn>
               <a:cxn ang="0">
-                <a:pos x="connsiteX13" y="connsiteY13"/>
+                <a:pos x="csX13" y="csY13"/>
               </a:cxn>
               <a:cxn ang="0">
-                <a:pos x="connsiteX14" y="connsiteY14"/>
+                <a:pos x="csX14" y="csY14"/>
               </a:cxn>
               <a:cxn ang="0">
-                <a:pos x="connsiteX15" y="connsiteY15"/>
+                <a:pos x="csX15" y="csY15"/>
               </a:cxn>
               <a:cxn ang="0">
-                <a:pos x="connsiteX16" y="connsiteY16"/>
+                <a:pos x="csX16" y="csY16"/>
               </a:cxn>
               <a:cxn ang="0">
-                <a:pos x="connsiteX17" y="connsiteY17"/>
+                <a:pos x="csX17" y="csY17"/>
               </a:cxn>
               <a:cxn ang="0">
-                <a:pos x="connsiteX18" y="connsiteY18"/>
+                <a:pos x="csX18" y="csY18"/>
               </a:cxn>
               <a:cxn ang="0">
-                <a:pos x="connsiteX19" y="connsiteY19"/>
+                <a:pos x="csX19" y="csY19"/>
               </a:cxn>
               <a:cxn ang="0">
-                <a:pos x="connsiteX20" y="connsiteY20"/>
-              </a:cxn>
-              <a:cxn ang="0">
-                <a:pos x="connsiteX21" y="connsiteY21"/>
-              </a:cxn>
-              <a:cxn ang="0">
-                <a:pos x="connsiteX22" y="connsiteY22"/>
-              </a:cxn>
-              <a:cxn ang="0">
-                <a:pos x="connsiteX23" y="connsiteY23"/>
-              </a:cxn>
-              <a:cxn ang="0">
-                <a:pos x="connsiteX24" y="connsiteY24"/>
-              </a:cxn>
-              <a:cxn ang="0">
-                <a:pos x="connsiteX25" y="connsiteY25"/>
+                <a:pos x="csX20" y="csY20"/>
               </a:cxn>
             </a:cxnLst>
             <a:rect l="l" t="t" r="r" b="b"/>
             <a:pathLst>
-              <a:path w="6861231" h="9144000">
+              <a:path w="6858000" h="9144000">
                 <a:moveTo>
-                  <a:pt x="3739836" y="8661917"/>
+                  <a:pt x="3717793" y="8656386"/>
                 </a:moveTo>
                 <a:lnTo>
-                  <a:pt x="3739836" y="8715917"/>
+                  <a:pt x="3717793" y="8710386"/>
                 </a:lnTo>
                 <a:lnTo>
-                  <a:pt x="6333058" y="8715917"/>
+                  <a:pt x="6309793" y="8710386"/>
                 </a:lnTo>
                 <a:lnTo>
-                  <a:pt x="6333058" y="8661917"/>
+                  <a:pt x="6309793" y="8656386"/>
                 </a:lnTo>
                 <a:close/>
                 <a:moveTo>
-                  <a:pt x="558032" y="8661917"/>
+                  <a:pt x="537487" y="8656386"/>
                 </a:moveTo>
                 <a:lnTo>
-                  <a:pt x="558032" y="8715917"/>
+                  <a:pt x="537487" y="8710386"/>
                 </a:lnTo>
                 <a:lnTo>
-                  <a:pt x="3151253" y="8715917"/>
+                  <a:pt x="3129487" y="8710386"/>
                 </a:lnTo>
                 <a:lnTo>
-                  <a:pt x="3151253" y="8661917"/>
+                  <a:pt x="3129487" y="8656386"/>
                 </a:lnTo>
                 <a:close/>
                 <a:moveTo>
-                  <a:pt x="651915" y="7301051"/>
+                  <a:pt x="651459" y="672371"/>
                 </a:moveTo>
                 <a:cubicBezTo>
-                  <a:pt x="595397" y="7301051"/>
-                  <a:pt x="549580" y="7346868"/>
-                  <a:pt x="549580" y="7403386"/>
+                  <a:pt x="594941" y="672371"/>
+                  <a:pt x="549124" y="718188"/>
+                  <a:pt x="549124" y="774706"/>
                 </a:cubicBezTo>
                 <a:cubicBezTo>
-                  <a:pt x="549580" y="7459904"/>
-                  <a:pt x="595397" y="7505721"/>
-                  <a:pt x="651915" y="7505721"/>
+                  <a:pt x="549124" y="831224"/>
+                  <a:pt x="594941" y="877041"/>
+                  <a:pt x="651459" y="877041"/>
                 </a:cubicBezTo>
                 <a:cubicBezTo>
-                  <a:pt x="708433" y="7505721"/>
-                  <a:pt x="754250" y="7459904"/>
-                  <a:pt x="754250" y="7403386"/>
+                  <a:pt x="707977" y="877041"/>
+                  <a:pt x="753794" y="831224"/>
+                  <a:pt x="753794" y="774706"/>
                 </a:cubicBezTo>
                 <a:cubicBezTo>
-                  <a:pt x="754250" y="7346868"/>
-                  <a:pt x="708433" y="7301051"/>
-                  <a:pt x="651915" y="7301051"/>
+                  <a:pt x="753794" y="718188"/>
+                  <a:pt x="707977" y="672371"/>
+                  <a:pt x="651459" y="672371"/>
                 </a:cubicBezTo>
                 <a:close/>
                 <a:moveTo>
-                  <a:pt x="672058" y="677902"/>
-                </a:moveTo>
-                <a:cubicBezTo>
-                  <a:pt x="615513" y="677902"/>
-                  <a:pt x="569674" y="723719"/>
-                  <a:pt x="569674" y="780237"/>
-                </a:cubicBezTo>
-                <a:cubicBezTo>
-                  <a:pt x="569674" y="836755"/>
-                  <a:pt x="615513" y="882572"/>
-                  <a:pt x="672058" y="882572"/>
-                </a:cubicBezTo>
-                <a:cubicBezTo>
-                  <a:pt x="728602" y="882572"/>
-                  <a:pt x="774441" y="836755"/>
-                  <a:pt x="774441" y="780237"/>
-                </a:cubicBezTo>
-                <a:cubicBezTo>
-                  <a:pt x="774441" y="723719"/>
-                  <a:pt x="728602" y="677902"/>
-                  <a:pt x="672058" y="677902"/>
-                </a:cubicBezTo>
-                <a:close/>
-                <a:moveTo>
-                  <a:pt x="558031" y="452468"/>
+                  <a:pt x="537486" y="446937"/>
                 </a:moveTo>
                 <a:lnTo>
-                  <a:pt x="558031" y="506468"/>
+                  <a:pt x="537486" y="500937"/>
                 </a:lnTo>
                 <a:lnTo>
-                  <a:pt x="6316936" y="506468"/>
+                  <a:pt x="6293679" y="500937"/>
                 </a:lnTo>
                 <a:lnTo>
-                  <a:pt x="6316936" y="452468"/>
+                  <a:pt x="6293679" y="446937"/>
                 </a:lnTo>
                 <a:close/>
                 <a:moveTo>
                   <a:pt x="0" y="0"/>
                 </a:moveTo>
                 <a:lnTo>
-                  <a:pt x="6861231" y="0"/>
+                  <a:pt x="6858000" y="0"/>
                 </a:lnTo>
                 <a:lnTo>
-                  <a:pt x="6861231" y="9144000"/>
+                  <a:pt x="6858000" y="9144000"/>
                 </a:lnTo>
                 <a:lnTo>
                   <a:pt x="0" y="9144000"/>
@@ -10269,12 +10221,159 @@
           </a:p>
         </p:txBody>
       </p:sp>
+      <p:sp>
+        <p:nvSpPr>
+          <p:cNvPr id="17" name="テキスト ボックス 16">
+            <a:extLst>
+              <a:ext uri="{FF2B5EF4-FFF2-40B4-BE49-F238E27FC236}">
+                <a16:creationId xmlns:a16="http://schemas.microsoft.com/office/drawing/2014/main" id="{CF4FD039-D677-D485-74F5-B3E184B86557}"/>
+              </a:ext>
+            </a:extLst>
+          </p:cNvPr>
+          <p:cNvSpPr txBox="1"/>
+          <p:nvPr/>
+        </p:nvSpPr>
+        <p:spPr>
+          <a:xfrm>
+            <a:off x="3163826" y="8511531"/>
+            <a:ext cx="575734" cy="369332"/>
+          </a:xfrm>
+          <a:prstGeom prst="rect">
+            <a:avLst/>
+          </a:prstGeom>
+          <a:noFill/>
+        </p:spPr>
+        <p:txBody>
+          <a:bodyPr wrap="square" rtlCol="0" anchor="ctr">
+            <a:spAutoFit/>
+          </a:bodyPr>
+          <a:lstStyle/>
+          <a:p>
+            <a:pPr algn="ctr"/>
+            <a:r>
+              <a:rPr kumimoji="1" lang="en-US" altLang="ja-JP" dirty="0"/>
+              <a:t>3</a:t>
+            </a:r>
+            <a:endParaRPr kumimoji="1" lang="ja-JP" altLang="en-US" dirty="0"/>
+          </a:p>
+        </p:txBody>
+      </p:sp>
+      <p:sp>
+        <p:nvSpPr>
+          <p:cNvPr id="31" name="テキスト ボックス 30">
+            <a:extLst>
+              <a:ext uri="{FF2B5EF4-FFF2-40B4-BE49-F238E27FC236}">
+                <a16:creationId xmlns:a16="http://schemas.microsoft.com/office/drawing/2014/main" id="{402917BB-FF52-F269-CC95-0E12909AB302}"/>
+              </a:ext>
+            </a:extLst>
+          </p:cNvPr>
+          <p:cNvSpPr txBox="1"/>
+          <p:nvPr/>
+        </p:nvSpPr>
+        <p:spPr>
+          <a:xfrm>
+            <a:off x="770844" y="610017"/>
+            <a:ext cx="2739853" cy="400110"/>
+          </a:xfrm>
+          <a:prstGeom prst="rect">
+            <a:avLst/>
+          </a:prstGeom>
+          <a:noFill/>
+        </p:spPr>
+        <p:txBody>
+          <a:bodyPr wrap="none" rtlCol="0">
+            <a:spAutoFit/>
+          </a:bodyPr>
+          <a:lstStyle/>
+          <a:p>
+            <a:r>
+              <a:rPr lang="en-US" altLang="ja-JP" sz="2000" dirty="0">
+                <a:latin typeface="IBM Plex Sans JP SemiBold" panose="020B0703050203000203" pitchFamily="50" charset="-128"/>
+                <a:ea typeface="IBM Plex Sans JP SemiBold" panose="020B0703050203000203" pitchFamily="50" charset="-128"/>
+              </a:rPr>
+              <a:t>5. Gradient Filament</a:t>
+            </a:r>
+            <a:endParaRPr kumimoji="1" lang="ja-JP" altLang="en-US" sz="2400" b="1" dirty="0">
+              <a:latin typeface="IBM Plex Sans JP SemiBold" panose="020B0703050203000203" pitchFamily="50" charset="-128"/>
+              <a:ea typeface="IBM Plex Sans JP SemiBold" panose="020B0703050203000203" pitchFamily="50" charset="-128"/>
+            </a:endParaRPr>
+          </a:p>
+        </p:txBody>
+      </p:sp>
+      <p:sp>
+        <p:nvSpPr>
+          <p:cNvPr id="33" name="テキスト ボックス 32">
+            <a:extLst>
+              <a:ext uri="{FF2B5EF4-FFF2-40B4-BE49-F238E27FC236}">
+                <a16:creationId xmlns:a16="http://schemas.microsoft.com/office/drawing/2014/main" id="{9C424B16-8EDA-50E2-DF24-F9EDAC56C05B}"/>
+              </a:ext>
+            </a:extLst>
+          </p:cNvPr>
+          <p:cNvSpPr txBox="1"/>
+          <p:nvPr/>
+        </p:nvSpPr>
+        <p:spPr>
+          <a:xfrm>
+            <a:off x="675778" y="4341274"/>
+            <a:ext cx="5642222" cy="246221"/>
+          </a:xfrm>
+          <a:prstGeom prst="rect">
+            <a:avLst/>
+          </a:prstGeom>
+          <a:noFill/>
+        </p:spPr>
+        <p:txBody>
+          <a:bodyPr wrap="square" rtlCol="0">
+            <a:spAutoFit/>
+          </a:bodyPr>
+          <a:lstStyle/>
+          <a:p>
+            <a:r>
+              <a:rPr lang="en-US" altLang="ja-JP" sz="1000" dirty="0">
+                <a:latin typeface="IBM Plex Sans JP" panose="020B0503050203000203" pitchFamily="50" charset="-128"/>
+                <a:ea typeface="IBM Plex Sans JP" panose="020B0503050203000203" pitchFamily="50" charset="-128"/>
+              </a:rPr>
+              <a:t>The following is the model configuration for Gradient Filament.</a:t>
+            </a:r>
+          </a:p>
+        </p:txBody>
+      </p:sp>
       <p:pic>
         <p:nvPicPr>
           <p:cNvPr id="4" name="図 3">
             <a:extLst>
               <a:ext uri="{FF2B5EF4-FFF2-40B4-BE49-F238E27FC236}">
-                <a16:creationId xmlns:a16="http://schemas.microsoft.com/office/drawing/2014/main" id="{65EBD496-4320-F95D-E4F6-46AE1204BBFD}"/>
+                <a16:creationId xmlns:a16="http://schemas.microsoft.com/office/drawing/2014/main" id="{3FA3831D-D4BD-0548-916E-1ED70DB39443}"/>
+              </a:ext>
+            </a:extLst>
+          </p:cNvPr>
+          <p:cNvPicPr>
+            <a:picLocks noChangeAspect="1"/>
+          </p:cNvPicPr>
+          <p:nvPr/>
+        </p:nvPicPr>
+        <p:blipFill>
+          <a:blip r:embed="rId2"/>
+          <a:stretch>
+            <a:fillRect/>
+          </a:stretch>
+        </p:blipFill>
+        <p:spPr>
+          <a:xfrm>
+            <a:off x="666614" y="4667054"/>
+            <a:ext cx="5521536" cy="3874587"/>
+          </a:xfrm>
+          <a:prstGeom prst="rect">
+            <a:avLst/>
+          </a:prstGeom>
+        </p:spPr>
+      </p:pic>
+      <p:pic>
+        <p:nvPicPr>
+          <p:cNvPr id="12" name="図 11">
+            <a:extLst>
+              <a:ext uri="{FF2B5EF4-FFF2-40B4-BE49-F238E27FC236}">
+                <a16:creationId xmlns:a16="http://schemas.microsoft.com/office/drawing/2014/main" id="{F961B068-E9D8-B96D-B744-D3A22DDD5E18}"/>
               </a:ext>
             </a:extLst>
           </p:cNvPr>
@@ -10284,7 +10383,7 @@
           <p:nvPr/>
         </p:nvPicPr>
         <p:blipFill>
-          <a:blip r:embed="rId2">
+          <a:blip r:embed="rId3">
             <a:extLst>
               <a:ext uri="{28A0092B-C50C-407E-A947-70E740481C1C}">
                 <a14:useLocalDpi xmlns:a14="http://schemas.microsoft.com/office/drawing/2010/main" val="0"/>
@@ -10298,7 +10397,7 @@
         </p:blipFill>
         <p:spPr bwMode="auto">
           <a:xfrm>
-            <a:off x="6711145" y="3652920"/>
+            <a:off x="609082" y="3243238"/>
             <a:ext cx="5636600" cy="919080"/>
           </a:xfrm>
           <a:prstGeom prst="rect">
@@ -10318,10 +10417,10 @@
       </p:pic>
       <p:sp>
         <p:nvSpPr>
-          <p:cNvPr id="17" name="テキスト ボックス 16">
+          <p:cNvPr id="19" name="テキスト ボックス 18">
             <a:extLst>
               <a:ext uri="{FF2B5EF4-FFF2-40B4-BE49-F238E27FC236}">
-                <a16:creationId xmlns:a16="http://schemas.microsoft.com/office/drawing/2014/main" id="{DDFACC84-E7FE-11C7-6620-F3DEFEB06920}"/>
+                <a16:creationId xmlns:a16="http://schemas.microsoft.com/office/drawing/2014/main" id="{EC269278-E84C-3A0D-7F7F-F9CC24F59D7B}"/>
               </a:ext>
             </a:extLst>
           </p:cNvPr>
@@ -10330,8 +10429,8 @@
         </p:nvSpPr>
         <p:spPr>
           <a:xfrm>
-            <a:off x="3163826" y="8511531"/>
-            <a:ext cx="575734" cy="369332"/>
+            <a:off x="668508" y="1032957"/>
+            <a:ext cx="5649491" cy="2031325"/>
           </a:xfrm>
           <a:prstGeom prst="rect">
             <a:avLst/>
@@ -10339,26 +10438,428 @@
           <a:noFill/>
         </p:spPr>
         <p:txBody>
-          <a:bodyPr wrap="square" rtlCol="0" anchor="ctr">
+          <a:bodyPr wrap="square" rtlCol="0">
             <a:spAutoFit/>
           </a:bodyPr>
           <a:lstStyle/>
           <a:p>
-            <a:pPr algn="ctr"/>
-            <a:r>
-              <a:rPr kumimoji="1" lang="en-US" altLang="ja-JP" dirty="0"/>
-              <a:t>3</a:t>
-            </a:r>
-            <a:endParaRPr kumimoji="1" lang="ja-JP" altLang="en-US" dirty="0"/>
-          </a:p>
-        </p:txBody>
-      </p:sp>
-      <p:sp>
-        <p:nvSpPr>
-          <p:cNvPr id="18" name="テキスト ボックス 17">
+            <a:r>
+              <a:rPr lang="en-US" altLang="ja-JP" sz="1000" dirty="0">
+                <a:latin typeface="IBM Plex Sans JP" panose="020B0503050203000203" pitchFamily="50" charset="-128"/>
+                <a:ea typeface="IBM Plex Sans JP" panose="020B0503050203000203" pitchFamily="50" charset="-128"/>
+              </a:rPr>
+              <a:t>The Gradient Filament Series provides multiple color-changing Profiles and Plates with different cycle counts. Details vary by model, so please refer to each model’s description.</a:t>
+            </a:r>
+          </a:p>
+          <a:p>
+            <a:endParaRPr lang="en-US" altLang="ja-JP" sz="1000" dirty="0">
+              <a:latin typeface="IBM Plex Sans JP" panose="020B0503050203000203" pitchFamily="50" charset="-128"/>
+              <a:ea typeface="IBM Plex Sans JP" panose="020B0503050203000203" pitchFamily="50" charset="-128"/>
+            </a:endParaRPr>
+          </a:p>
+          <a:p>
+            <a:pPr marL="171450" indent="-171450">
+              <a:buFont typeface="Arial" panose="020B0604020202020204" pitchFamily="34" charset="0"/>
+              <a:buChar char="•"/>
+            </a:pPr>
+            <a:r>
+              <a:rPr lang="en-US" altLang="ja-JP" sz="1000" dirty="0">
+                <a:latin typeface="IBM Plex Sans JP" panose="020B0503050203000203" pitchFamily="50" charset="-128"/>
+                <a:ea typeface="IBM Plex Sans JP" panose="020B0503050203000203" pitchFamily="50" charset="-128"/>
+              </a:rPr>
+              <a:t>Color Curve: Settings based on color combinations. This option allows you to select the optimal gradient for each color—for example, “Vivid” for cyan and yellow, or “Contrast” for white and magenta.</a:t>
+            </a:r>
+          </a:p>
+          <a:p>
+            <a:endParaRPr lang="en-US" altLang="ja-JP" sz="600" dirty="0">
+              <a:latin typeface="IBM Plex Sans JP" panose="020B0503050203000203" pitchFamily="50" charset="-128"/>
+              <a:ea typeface="IBM Plex Sans JP" panose="020B0503050203000203" pitchFamily="50" charset="-128"/>
+            </a:endParaRPr>
+          </a:p>
+          <a:p>
+            <a:pPr marL="171450" indent="-171450">
+              <a:buFont typeface="Arial" panose="020B0604020202020204" pitchFamily="34" charset="0"/>
+              <a:buChar char="•"/>
+            </a:pPr>
+            <a:r>
+              <a:rPr lang="en-US" altLang="ja-JP" sz="1000" dirty="0">
+                <a:latin typeface="IBM Plex Sans JP" panose="020B0503050203000203" pitchFamily="50" charset="-128"/>
+                <a:ea typeface="IBM Plex Sans JP" panose="020B0503050203000203" pitchFamily="50" charset="-128"/>
+              </a:rPr>
+              <a:t>Number of cycles: The number that determines the frequency of the gradient. One cycle is counted as one complete cycle in which the filament changes from A to B to A and back.</a:t>
+            </a:r>
+          </a:p>
+          <a:p>
+            <a:endParaRPr lang="en-US" altLang="ja-JP" sz="1000" dirty="0">
+              <a:latin typeface="IBM Plex Sans JP" panose="020B0503050203000203" pitchFamily="50" charset="-128"/>
+              <a:ea typeface="IBM Plex Sans JP" panose="020B0503050203000203" pitchFamily="50" charset="-128"/>
+            </a:endParaRPr>
+          </a:p>
+          <a:p>
+            <a:r>
+              <a:rPr lang="en-US" altLang="ja-JP" sz="1000" dirty="0">
+                <a:latin typeface="IBM Plex Sans JP" panose="020B0503050203000203" pitchFamily="50" charset="-128"/>
+                <a:ea typeface="IBM Plex Sans JP" panose="020B0503050203000203" pitchFamily="50" charset="-128"/>
+              </a:rPr>
+              <a:t>Example: To create a fast-cycle gradient filament using cyan and magenta, select an S4 Model, choose a 4-cycle Plate, and use the Vivid curve Profile due to the high color contrast.</a:t>
+            </a:r>
+            <a:endParaRPr kumimoji="1" lang="ja-JP" altLang="en-US" sz="1000" b="1" dirty="0">
+              <a:latin typeface="IBM Plex Sans JP" panose="020B0503050203000203" pitchFamily="50" charset="-128"/>
+              <a:ea typeface="IBM Plex Sans JP" panose="020B0503050203000203" pitchFamily="50" charset="-128"/>
+            </a:endParaRPr>
+          </a:p>
+        </p:txBody>
+      </p:sp>
+    </p:spTree>
+    <p:extLst>
+      <p:ext uri="{BB962C8B-B14F-4D97-AF65-F5344CB8AC3E}">
+        <p14:creationId xmlns:p14="http://schemas.microsoft.com/office/powerpoint/2010/main" val="4292805330"/>
+      </p:ext>
+    </p:extLst>
+  </p:cSld>
+  <p:clrMapOvr>
+    <a:masterClrMapping/>
+  </p:clrMapOvr>
+</p:sld>
+</file>
+
+<file path=ppt/slides/slide9.xml><?xml version="1.0" encoding="utf-8"?>
+<p:sld xmlns:a="http://schemas.openxmlformats.org/drawingml/2006/main" xmlns:r="http://schemas.openxmlformats.org/officeDocument/2006/relationships" xmlns:p="http://schemas.openxmlformats.org/presentationml/2006/main">
+  <p:cSld>
+    <p:spTree>
+      <p:nvGrpSpPr>
+        <p:cNvPr id="1" name="">
+          <a:extLst>
+            <a:ext uri="{FF2B5EF4-FFF2-40B4-BE49-F238E27FC236}">
+              <a16:creationId xmlns:a16="http://schemas.microsoft.com/office/drawing/2014/main" id="{7125A6E3-FC4A-AC00-A897-53FC35BE1199}"/>
+            </a:ext>
+          </a:extLst>
+        </p:cNvPr>
+        <p:cNvGrpSpPr/>
+        <p:nvPr/>
+      </p:nvGrpSpPr>
+      <p:grpSpPr>
+        <a:xfrm>
+          <a:off x="0" y="0"/>
+          <a:ext cx="0" cy="0"/>
+          <a:chOff x="0" y="0"/>
+          <a:chExt cx="0" cy="0"/>
+        </a:xfrm>
+      </p:grpSpPr>
+      <p:sp>
+        <p:nvSpPr>
+          <p:cNvPr id="30" name="正方形/長方形 29">
             <a:extLst>
               <a:ext uri="{FF2B5EF4-FFF2-40B4-BE49-F238E27FC236}">
-                <a16:creationId xmlns:a16="http://schemas.microsoft.com/office/drawing/2014/main" id="{AEF844E9-5EE0-D507-0BE6-EA50C139ECC5}"/>
+                <a16:creationId xmlns:a16="http://schemas.microsoft.com/office/drawing/2014/main" id="{53908D35-F986-58BC-278C-A39AF70B18D9}"/>
+              </a:ext>
+            </a:extLst>
+          </p:cNvPr>
+          <p:cNvSpPr/>
+          <p:nvPr/>
+        </p:nvSpPr>
+        <p:spPr>
+          <a:xfrm>
+            <a:off x="51086" y="45268"/>
+            <a:ext cx="6790099" cy="9053465"/>
+          </a:xfrm>
+          <a:prstGeom prst="rect">
+            <a:avLst/>
+          </a:prstGeom>
+          <a:gradFill>
+            <a:gsLst>
+              <a:gs pos="50000">
+                <a:srgbClr val="6200E8"/>
+              </a:gs>
+              <a:gs pos="10000">
+                <a:srgbClr val="EE00B0"/>
+              </a:gs>
+              <a:gs pos="90000">
+                <a:srgbClr val="0095E5"/>
+              </a:gs>
+            </a:gsLst>
+            <a:lin ang="1800000" scaled="0"/>
+          </a:gradFill>
+          <a:ln>
+            <a:noFill/>
+          </a:ln>
+        </p:spPr>
+        <p:style>
+          <a:lnRef idx="2">
+            <a:schemeClr val="accent1">
+              <a:shade val="15000"/>
+            </a:schemeClr>
+          </a:lnRef>
+          <a:fillRef idx="1">
+            <a:schemeClr val="accent1"/>
+          </a:fillRef>
+          <a:effectRef idx="0">
+            <a:schemeClr val="accent1"/>
+          </a:effectRef>
+          <a:fontRef idx="minor">
+            <a:schemeClr val="lt1"/>
+          </a:fontRef>
+        </p:style>
+        <p:txBody>
+          <a:bodyPr rtlCol="0" anchor="ctr"/>
+          <a:lstStyle/>
+          <a:p>
+            <a:pPr algn="ctr"/>
+            <a:endParaRPr kumimoji="1" lang="ja-JP" altLang="en-US" dirty="0"/>
+          </a:p>
+        </p:txBody>
+      </p:sp>
+      <p:sp>
+        <p:nvSpPr>
+          <p:cNvPr id="12" name="フリーフォーム: 図形 11">
+            <a:extLst>
+              <a:ext uri="{FF2B5EF4-FFF2-40B4-BE49-F238E27FC236}">
+                <a16:creationId xmlns:a16="http://schemas.microsoft.com/office/drawing/2014/main" id="{B1005370-E423-EBFF-F31C-32291B3DE46C}"/>
+              </a:ext>
+            </a:extLst>
+          </p:cNvPr>
+          <p:cNvSpPr/>
+          <p:nvPr/>
+        </p:nvSpPr>
+        <p:spPr>
+          <a:xfrm>
+            <a:off x="17051" y="5531"/>
+            <a:ext cx="6858000" cy="9144000"/>
+          </a:xfrm>
+          <a:custGeom>
+            <a:avLst/>
+            <a:gdLst>
+              <a:gd name="csX0" fmla="*/ 3717793 w 6858000"/>
+              <a:gd name="csY0" fmla="*/ 8656386 h 9144000"/>
+              <a:gd name="csX1" fmla="*/ 3717793 w 6858000"/>
+              <a:gd name="csY1" fmla="*/ 8710386 h 9144000"/>
+              <a:gd name="csX2" fmla="*/ 6309793 w 6858000"/>
+              <a:gd name="csY2" fmla="*/ 8710386 h 9144000"/>
+              <a:gd name="csX3" fmla="*/ 6309793 w 6858000"/>
+              <a:gd name="csY3" fmla="*/ 8656386 h 9144000"/>
+              <a:gd name="csX4" fmla="*/ 537487 w 6858000"/>
+              <a:gd name="csY4" fmla="*/ 8656386 h 9144000"/>
+              <a:gd name="csX5" fmla="*/ 537487 w 6858000"/>
+              <a:gd name="csY5" fmla="*/ 8710386 h 9144000"/>
+              <a:gd name="csX6" fmla="*/ 3129487 w 6858000"/>
+              <a:gd name="csY6" fmla="*/ 8710386 h 9144000"/>
+              <a:gd name="csX7" fmla="*/ 3129487 w 6858000"/>
+              <a:gd name="csY7" fmla="*/ 8656386 h 9144000"/>
+              <a:gd name="csX8" fmla="*/ 631632 w 6858000"/>
+              <a:gd name="csY8" fmla="*/ 811545 h 9144000"/>
+              <a:gd name="csX9" fmla="*/ 529297 w 6858000"/>
+              <a:gd name="csY9" fmla="*/ 913880 h 9144000"/>
+              <a:gd name="csX10" fmla="*/ 631632 w 6858000"/>
+              <a:gd name="csY10" fmla="*/ 1016215 h 9144000"/>
+              <a:gd name="csX11" fmla="*/ 733967 w 6858000"/>
+              <a:gd name="csY11" fmla="*/ 913880 h 9144000"/>
+              <a:gd name="csX12" fmla="*/ 631632 w 6858000"/>
+              <a:gd name="csY12" fmla="*/ 811545 h 9144000"/>
+              <a:gd name="csX13" fmla="*/ 537486 w 6858000"/>
+              <a:gd name="csY13" fmla="*/ 446937 h 9144000"/>
+              <a:gd name="csX14" fmla="*/ 537486 w 6858000"/>
+              <a:gd name="csY14" fmla="*/ 500937 h 9144000"/>
+              <a:gd name="csX15" fmla="*/ 6293679 w 6858000"/>
+              <a:gd name="csY15" fmla="*/ 500937 h 9144000"/>
+              <a:gd name="csX16" fmla="*/ 6293679 w 6858000"/>
+              <a:gd name="csY16" fmla="*/ 446937 h 9144000"/>
+              <a:gd name="csX17" fmla="*/ 0 w 6858000"/>
+              <a:gd name="csY17" fmla="*/ 0 h 9144000"/>
+              <a:gd name="csX18" fmla="*/ 6858000 w 6858000"/>
+              <a:gd name="csY18" fmla="*/ 0 h 9144000"/>
+              <a:gd name="csX19" fmla="*/ 6858000 w 6858000"/>
+              <a:gd name="csY19" fmla="*/ 9144000 h 9144000"/>
+              <a:gd name="csX20" fmla="*/ 0 w 6858000"/>
+              <a:gd name="csY20" fmla="*/ 9144000 h 9144000"/>
+            </a:gdLst>
+            <a:ahLst/>
+            <a:cxnLst>
+              <a:cxn ang="0">
+                <a:pos x="csX0" y="csY0"/>
+              </a:cxn>
+              <a:cxn ang="0">
+                <a:pos x="csX1" y="csY1"/>
+              </a:cxn>
+              <a:cxn ang="0">
+                <a:pos x="csX2" y="csY2"/>
+              </a:cxn>
+              <a:cxn ang="0">
+                <a:pos x="csX3" y="csY3"/>
+              </a:cxn>
+              <a:cxn ang="0">
+                <a:pos x="csX4" y="csY4"/>
+              </a:cxn>
+              <a:cxn ang="0">
+                <a:pos x="csX5" y="csY5"/>
+              </a:cxn>
+              <a:cxn ang="0">
+                <a:pos x="csX6" y="csY6"/>
+              </a:cxn>
+              <a:cxn ang="0">
+                <a:pos x="csX7" y="csY7"/>
+              </a:cxn>
+              <a:cxn ang="0">
+                <a:pos x="csX8" y="csY8"/>
+              </a:cxn>
+              <a:cxn ang="0">
+                <a:pos x="csX9" y="csY9"/>
+              </a:cxn>
+              <a:cxn ang="0">
+                <a:pos x="csX10" y="csY10"/>
+              </a:cxn>
+              <a:cxn ang="0">
+                <a:pos x="csX11" y="csY11"/>
+              </a:cxn>
+              <a:cxn ang="0">
+                <a:pos x="csX12" y="csY12"/>
+              </a:cxn>
+              <a:cxn ang="0">
+                <a:pos x="csX13" y="csY13"/>
+              </a:cxn>
+              <a:cxn ang="0">
+                <a:pos x="csX14" y="csY14"/>
+              </a:cxn>
+              <a:cxn ang="0">
+                <a:pos x="csX15" y="csY15"/>
+              </a:cxn>
+              <a:cxn ang="0">
+                <a:pos x="csX16" y="csY16"/>
+              </a:cxn>
+              <a:cxn ang="0">
+                <a:pos x="csX17" y="csY17"/>
+              </a:cxn>
+              <a:cxn ang="0">
+                <a:pos x="csX18" y="csY18"/>
+              </a:cxn>
+              <a:cxn ang="0">
+                <a:pos x="csX19" y="csY19"/>
+              </a:cxn>
+              <a:cxn ang="0">
+                <a:pos x="csX20" y="csY20"/>
+              </a:cxn>
+            </a:cxnLst>
+            <a:rect l="l" t="t" r="r" b="b"/>
+            <a:pathLst>
+              <a:path w="6858000" h="9144000">
+                <a:moveTo>
+                  <a:pt x="3717793" y="8656386"/>
+                </a:moveTo>
+                <a:lnTo>
+                  <a:pt x="3717793" y="8710386"/>
+                </a:lnTo>
+                <a:lnTo>
+                  <a:pt x="6309793" y="8710386"/>
+                </a:lnTo>
+                <a:lnTo>
+                  <a:pt x="6309793" y="8656386"/>
+                </a:lnTo>
+                <a:close/>
+                <a:moveTo>
+                  <a:pt x="537487" y="8656386"/>
+                </a:moveTo>
+                <a:lnTo>
+                  <a:pt x="537487" y="8710386"/>
+                </a:lnTo>
+                <a:lnTo>
+                  <a:pt x="3129487" y="8710386"/>
+                </a:lnTo>
+                <a:lnTo>
+                  <a:pt x="3129487" y="8656386"/>
+                </a:lnTo>
+                <a:close/>
+                <a:moveTo>
+                  <a:pt x="631632" y="811545"/>
+                </a:moveTo>
+                <a:cubicBezTo>
+                  <a:pt x="575114" y="811545"/>
+                  <a:pt x="529297" y="857362"/>
+                  <a:pt x="529297" y="913880"/>
+                </a:cubicBezTo>
+                <a:cubicBezTo>
+                  <a:pt x="529297" y="970398"/>
+                  <a:pt x="575114" y="1016215"/>
+                  <a:pt x="631632" y="1016215"/>
+                </a:cubicBezTo>
+                <a:cubicBezTo>
+                  <a:pt x="688150" y="1016215"/>
+                  <a:pt x="733967" y="970398"/>
+                  <a:pt x="733967" y="913880"/>
+                </a:cubicBezTo>
+                <a:cubicBezTo>
+                  <a:pt x="733967" y="857362"/>
+                  <a:pt x="688150" y="811545"/>
+                  <a:pt x="631632" y="811545"/>
+                </a:cubicBezTo>
+                <a:close/>
+                <a:moveTo>
+                  <a:pt x="537486" y="446937"/>
+                </a:moveTo>
+                <a:lnTo>
+                  <a:pt x="537486" y="500937"/>
+                </a:lnTo>
+                <a:lnTo>
+                  <a:pt x="6293679" y="500937"/>
+                </a:lnTo>
+                <a:lnTo>
+                  <a:pt x="6293679" y="446937"/>
+                </a:lnTo>
+                <a:close/>
+                <a:moveTo>
+                  <a:pt x="0" y="0"/>
+                </a:moveTo>
+                <a:lnTo>
+                  <a:pt x="6858000" y="0"/>
+                </a:lnTo>
+                <a:lnTo>
+                  <a:pt x="6858000" y="9144000"/>
+                </a:lnTo>
+                <a:lnTo>
+                  <a:pt x="0" y="9144000"/>
+                </a:lnTo>
+                <a:close/>
+              </a:path>
+            </a:pathLst>
+          </a:custGeom>
+          <a:solidFill>
+            <a:schemeClr val="bg1"/>
+          </a:solidFill>
+          <a:ln>
+            <a:noFill/>
+          </a:ln>
+        </p:spPr>
+        <p:style>
+          <a:lnRef idx="2">
+            <a:schemeClr val="accent1">
+              <a:shade val="15000"/>
+            </a:schemeClr>
+          </a:lnRef>
+          <a:fillRef idx="1">
+            <a:schemeClr val="accent1"/>
+          </a:fillRef>
+          <a:effectRef idx="0">
+            <a:schemeClr val="accent1"/>
+          </a:effectRef>
+          <a:fontRef idx="minor">
+            <a:schemeClr val="lt1"/>
+          </a:fontRef>
+        </p:style>
+        <p:txBody>
+          <a:bodyPr wrap="square" rtlCol="0" anchor="ctr">
+            <a:noAutofit/>
+          </a:bodyPr>
+          <a:lstStyle/>
+          <a:p>
+            <a:pPr algn="ctr"/>
+            <a:endParaRPr kumimoji="1" lang="ja-JP" altLang="en-US"/>
+          </a:p>
+        </p:txBody>
+      </p:sp>
+      <p:sp>
+        <p:nvSpPr>
+          <p:cNvPr id="17" name="テキスト ボックス 16">
+            <a:extLst>
+              <a:ext uri="{FF2B5EF4-FFF2-40B4-BE49-F238E27FC236}">
+                <a16:creationId xmlns:a16="http://schemas.microsoft.com/office/drawing/2014/main" id="{6F944542-F688-AA88-F03D-72137284BC20}"/>
               </a:ext>
             </a:extLst>
           </p:cNvPr>
@@ -10367,8 +10868,8 @@
         </p:nvSpPr>
         <p:spPr>
           <a:xfrm>
-            <a:off x="770844" y="610017"/>
-            <a:ext cx="2739853" cy="400110"/>
+            <a:off x="3163826" y="8511531"/>
+            <a:ext cx="575734" cy="369332"/>
           </a:xfrm>
           <a:prstGeom prst="rect">
             <a:avLst/>
@@ -10376,31 +10877,26 @@
           <a:noFill/>
         </p:spPr>
         <p:txBody>
-          <a:bodyPr wrap="none" rtlCol="0">
+          <a:bodyPr wrap="square" rtlCol="0" anchor="ctr">
             <a:spAutoFit/>
           </a:bodyPr>
           <a:lstStyle/>
           <a:p>
-            <a:r>
-              <a:rPr lang="en-US" altLang="ja-JP" sz="2000" dirty="0">
-                <a:latin typeface="IBM Plex Sans JP SemiBold" panose="020B0703050203000203" pitchFamily="50" charset="-128"/>
-                <a:ea typeface="IBM Plex Sans JP SemiBold" panose="020B0703050203000203" pitchFamily="50" charset="-128"/>
-              </a:rPr>
-              <a:t>5. Gradient Filament</a:t>
-            </a:r>
-            <a:endParaRPr kumimoji="1" lang="ja-JP" altLang="en-US" sz="2400" b="1" dirty="0">
-              <a:latin typeface="IBM Plex Sans JP SemiBold" panose="020B0703050203000203" pitchFamily="50" charset="-128"/>
-              <a:ea typeface="IBM Plex Sans JP SemiBold" panose="020B0703050203000203" pitchFamily="50" charset="-128"/>
-            </a:endParaRPr>
-          </a:p>
-        </p:txBody>
-      </p:sp>
-      <p:sp>
-        <p:nvSpPr>
-          <p:cNvPr id="19" name="テキスト ボックス 18">
+            <a:pPr algn="ctr"/>
+            <a:r>
+              <a:rPr kumimoji="1" lang="en-US" altLang="ja-JP" dirty="0"/>
+              <a:t>4</a:t>
+            </a:r>
+            <a:endParaRPr kumimoji="1" lang="ja-JP" altLang="en-US" dirty="0"/>
+          </a:p>
+        </p:txBody>
+      </p:sp>
+      <p:sp>
+        <p:nvSpPr>
+          <p:cNvPr id="34" name="テキスト ボックス 33">
             <a:extLst>
               <a:ext uri="{FF2B5EF4-FFF2-40B4-BE49-F238E27FC236}">
-                <a16:creationId xmlns:a16="http://schemas.microsoft.com/office/drawing/2014/main" id="{79E1405D-DAD0-B18A-CDD6-7E8756624CA9}"/>
+                <a16:creationId xmlns:a16="http://schemas.microsoft.com/office/drawing/2014/main" id="{5C2CABC6-218E-C4AF-5D73-A13394AD5453}"/>
               </a:ext>
             </a:extLst>
           </p:cNvPr>
@@ -10409,8 +10905,8 @@
         </p:nvSpPr>
         <p:spPr>
           <a:xfrm>
-            <a:off x="668508" y="1032957"/>
-            <a:ext cx="5649491" cy="2031325"/>
+            <a:off x="778114" y="784294"/>
+            <a:ext cx="1923925" cy="338554"/>
           </a:xfrm>
           <a:prstGeom prst="rect">
             <a:avLst/>
@@ -10418,84 +10914,31 @@
           <a:noFill/>
         </p:spPr>
         <p:txBody>
-          <a:bodyPr wrap="square" rtlCol="0">
+          <a:bodyPr wrap="none" rtlCol="0">
             <a:spAutoFit/>
           </a:bodyPr>
           <a:lstStyle/>
           <a:p>
             <a:r>
-              <a:rPr lang="en-US" altLang="ja-JP" sz="1000" dirty="0">
-                <a:latin typeface="IBM Plex Sans JP" panose="020B0503050203000203" pitchFamily="50" charset="-128"/>
-                <a:ea typeface="IBM Plex Sans JP" panose="020B0503050203000203" pitchFamily="50" charset="-128"/>
+              <a:rPr lang="en-US" altLang="ja-JP" sz="1600" dirty="0">
+                <a:latin typeface="IBM Plex Sans JP SemiBold" panose="020B0703050203000203" pitchFamily="50" charset="-128"/>
+                <a:ea typeface="IBM Plex Sans JP SemiBold" panose="020B0703050203000203" pitchFamily="50" charset="-128"/>
               </a:rPr>
-              <a:t>The Gradient Filament Series provides multiple color-changing Profiles and Plates with different cycle counts. Details vary by model, so please refer to each model’s description.</a:t>
-            </a:r>
-          </a:p>
-          <a:p>
-            <a:endParaRPr lang="en-US" altLang="ja-JP" sz="1000" dirty="0">
-              <a:latin typeface="IBM Plex Sans JP" panose="020B0503050203000203" pitchFamily="50" charset="-128"/>
-              <a:ea typeface="IBM Plex Sans JP" panose="020B0503050203000203" pitchFamily="50" charset="-128"/>
+              <a:t>6. Update History</a:t>
+            </a:r>
+            <a:endParaRPr kumimoji="1" lang="ja-JP" altLang="en-US" b="1" dirty="0">
+              <a:latin typeface="IBM Plex Sans JP SemiBold" panose="020B0703050203000203" pitchFamily="50" charset="-128"/>
+              <a:ea typeface="IBM Plex Sans JP SemiBold" panose="020B0703050203000203" pitchFamily="50" charset="-128"/>
             </a:endParaRPr>
           </a:p>
-          <a:p>
-            <a:pPr marL="171450" indent="-171450">
-              <a:buFont typeface="Arial" panose="020B0604020202020204" pitchFamily="34" charset="0"/>
-              <a:buChar char="•"/>
-            </a:pPr>
-            <a:r>
-              <a:rPr lang="en-US" altLang="ja-JP" sz="1000" dirty="0">
-                <a:latin typeface="IBM Plex Sans JP" panose="020B0503050203000203" pitchFamily="50" charset="-128"/>
-                <a:ea typeface="IBM Plex Sans JP" panose="020B0503050203000203" pitchFamily="50" charset="-128"/>
-              </a:rPr>
-              <a:t>Color Curve: Settings based on color combinations. This option allows you to select the optimal gradient for each color—for example, “Vivid” for cyan and yellow, or “Contrast” for white and magenta.</a:t>
-            </a:r>
-          </a:p>
-          <a:p>
-            <a:endParaRPr lang="en-US" altLang="ja-JP" sz="600" dirty="0">
-              <a:latin typeface="IBM Plex Sans JP" panose="020B0503050203000203" pitchFamily="50" charset="-128"/>
-              <a:ea typeface="IBM Plex Sans JP" panose="020B0503050203000203" pitchFamily="50" charset="-128"/>
-            </a:endParaRPr>
-          </a:p>
-          <a:p>
-            <a:pPr marL="171450" indent="-171450">
-              <a:buFont typeface="Arial" panose="020B0604020202020204" pitchFamily="34" charset="0"/>
-              <a:buChar char="•"/>
-            </a:pPr>
-            <a:r>
-              <a:rPr lang="en-US" altLang="ja-JP" sz="1000" dirty="0">
-                <a:latin typeface="IBM Plex Sans JP" panose="020B0503050203000203" pitchFamily="50" charset="-128"/>
-                <a:ea typeface="IBM Plex Sans JP" panose="020B0503050203000203" pitchFamily="50" charset="-128"/>
-              </a:rPr>
-              <a:t>Number of cycles: The number that determines the frequency of the gradient. One cycle is counted as one complete cycle in which the filament changes from A to B to A and back.</a:t>
-            </a:r>
-          </a:p>
-          <a:p>
-            <a:endParaRPr lang="en-US" altLang="ja-JP" sz="1000" dirty="0">
-              <a:latin typeface="IBM Plex Sans JP" panose="020B0503050203000203" pitchFamily="50" charset="-128"/>
-              <a:ea typeface="IBM Plex Sans JP" panose="020B0503050203000203" pitchFamily="50" charset="-128"/>
-            </a:endParaRPr>
-          </a:p>
-          <a:p>
-            <a:r>
-              <a:rPr lang="en-US" altLang="ja-JP" sz="1000" dirty="0">
-                <a:latin typeface="IBM Plex Sans JP" panose="020B0503050203000203" pitchFamily="50" charset="-128"/>
-                <a:ea typeface="IBM Plex Sans JP" panose="020B0503050203000203" pitchFamily="50" charset="-128"/>
-              </a:rPr>
-              <a:t>Example: To create a fast-cycle gradient filament using cyan and magenta, select an S4 Model, choose a 4-cycle Plate, and use the Vivid curve Profile due to the high color contrast.</a:t>
-            </a:r>
-            <a:endParaRPr kumimoji="1" lang="ja-JP" altLang="en-US" sz="1000" b="1" dirty="0">
-              <a:latin typeface="IBM Plex Sans JP" panose="020B0503050203000203" pitchFamily="50" charset="-128"/>
-              <a:ea typeface="IBM Plex Sans JP" panose="020B0503050203000203" pitchFamily="50" charset="-128"/>
-            </a:endParaRPr>
-          </a:p>
-        </p:txBody>
-      </p:sp>
-      <p:sp>
-        <p:nvSpPr>
-          <p:cNvPr id="25" name="テキスト ボックス 24">
+        </p:txBody>
+      </p:sp>
+      <p:sp>
+        <p:nvSpPr>
+          <p:cNvPr id="35" name="テキスト ボックス 34">
             <a:extLst>
               <a:ext uri="{FF2B5EF4-FFF2-40B4-BE49-F238E27FC236}">
-                <a16:creationId xmlns:a16="http://schemas.microsoft.com/office/drawing/2014/main" id="{7ED3E711-A061-E5B5-882E-75E8B78F5498}"/>
+                <a16:creationId xmlns:a16="http://schemas.microsoft.com/office/drawing/2014/main" id="{5FE1D15C-58BD-0ED2-6FA9-EDDD3C3FFB7D}"/>
               </a:ext>
             </a:extLst>
           </p:cNvPr>
@@ -10504,87 +10947,7 @@
         </p:nvSpPr>
         <p:spPr>
           <a:xfrm>
-            <a:off x="675778" y="2965281"/>
-            <a:ext cx="5642222" cy="246221"/>
-          </a:xfrm>
-          <a:prstGeom prst="rect">
-            <a:avLst/>
-          </a:prstGeom>
-          <a:noFill/>
-        </p:spPr>
-        <p:txBody>
-          <a:bodyPr wrap="square" rtlCol="0">
-            <a:spAutoFit/>
-          </a:bodyPr>
-          <a:lstStyle/>
-          <a:p>
-            <a:r>
-              <a:rPr lang="en-US" altLang="ja-JP" sz="1000" dirty="0">
-                <a:latin typeface="IBM Plex Sans JP" panose="020B0503050203000203" pitchFamily="50" charset="-128"/>
-                <a:ea typeface="IBM Plex Sans JP" panose="020B0503050203000203" pitchFamily="50" charset="-128"/>
-              </a:rPr>
-              <a:t>The following is the model configuration for Gradient Filament.</a:t>
-            </a:r>
-          </a:p>
-        </p:txBody>
-      </p:sp>
-      <p:sp>
-        <p:nvSpPr>
-          <p:cNvPr id="5" name="テキスト ボックス 4">
-            <a:extLst>
-              <a:ext uri="{FF2B5EF4-FFF2-40B4-BE49-F238E27FC236}">
-                <a16:creationId xmlns:a16="http://schemas.microsoft.com/office/drawing/2014/main" id="{46940E87-7400-BF59-728F-D232492BBE36}"/>
-              </a:ext>
-            </a:extLst>
-          </p:cNvPr>
-          <p:cNvSpPr txBox="1"/>
-          <p:nvPr/>
-        </p:nvSpPr>
-        <p:spPr>
-          <a:xfrm>
-            <a:off x="778114" y="7268269"/>
-            <a:ext cx="1923925" cy="338554"/>
-          </a:xfrm>
-          <a:prstGeom prst="rect">
-            <a:avLst/>
-          </a:prstGeom>
-          <a:noFill/>
-        </p:spPr>
-        <p:txBody>
-          <a:bodyPr wrap="none" rtlCol="0">
-            <a:spAutoFit/>
-          </a:bodyPr>
-          <a:lstStyle/>
-          <a:p>
-            <a:r>
-              <a:rPr lang="en-US" altLang="ja-JP" sz="1600" dirty="0">
-                <a:latin typeface="IBM Plex Sans JP SemiBold" panose="020B0703050203000203" pitchFamily="50" charset="-128"/>
-                <a:ea typeface="IBM Plex Sans JP SemiBold" panose="020B0703050203000203" pitchFamily="50" charset="-128"/>
-              </a:rPr>
-              <a:t>6. Update History</a:t>
-            </a:r>
-            <a:endParaRPr kumimoji="1" lang="ja-JP" altLang="en-US" b="1" dirty="0">
-              <a:latin typeface="IBM Plex Sans JP SemiBold" panose="020B0703050203000203" pitchFamily="50" charset="-128"/>
-              <a:ea typeface="IBM Plex Sans JP SemiBold" panose="020B0703050203000203" pitchFamily="50" charset="-128"/>
-            </a:endParaRPr>
-          </a:p>
-        </p:txBody>
-      </p:sp>
-      <p:sp>
-        <p:nvSpPr>
-          <p:cNvPr id="6" name="テキスト ボックス 5">
-            <a:extLst>
-              <a:ext uri="{FF2B5EF4-FFF2-40B4-BE49-F238E27FC236}">
-                <a16:creationId xmlns:a16="http://schemas.microsoft.com/office/drawing/2014/main" id="{772E1925-419D-E6C3-9438-BD98D2BBDD58}"/>
-              </a:ext>
-            </a:extLst>
-          </p:cNvPr>
-          <p:cNvSpPr txBox="1"/>
-          <p:nvPr/>
-        </p:nvSpPr>
-        <p:spPr>
-          <a:xfrm>
-            <a:off x="638323" y="7599215"/>
+            <a:off x="638323" y="1115240"/>
             <a:ext cx="5649491" cy="507831"/>
           </a:xfrm>
           <a:prstGeom prst="rect">
@@ -10612,51 +10975,24 @@
                 <a:latin typeface="IBM Plex Sans JP" panose="020B0503050203000203" pitchFamily="50" charset="-128"/>
                 <a:ea typeface="IBM Plex Sans JP" panose="020B0503050203000203" pitchFamily="50" charset="-128"/>
               </a:rPr>
-              <a:t>Ver.1.10  2026-07-02  Revisions for Integrated Design</a:t>
-            </a:r>
-          </a:p>
-          <a:p>
-            <a:endParaRPr kumimoji="1" lang="ja-JP" altLang="en-US" sz="900" b="1" dirty="0">
-              <a:latin typeface="IBM Plex Sans JP" panose="020B0503050203000203" pitchFamily="50" charset="-128"/>
-              <a:ea typeface="IBM Plex Sans JP" panose="020B0503050203000203" pitchFamily="50" charset="-128"/>
-            </a:endParaRPr>
-          </a:p>
-        </p:txBody>
-      </p:sp>
-      <p:pic>
-        <p:nvPicPr>
-          <p:cNvPr id="9" name="図 8">
-            <a:extLst>
-              <a:ext uri="{FF2B5EF4-FFF2-40B4-BE49-F238E27FC236}">
-                <a16:creationId xmlns:a16="http://schemas.microsoft.com/office/drawing/2014/main" id="{0012A0F4-0BEF-52F9-839A-7754F15453D4}"/>
-              </a:ext>
-            </a:extLst>
-          </p:cNvPr>
-          <p:cNvPicPr>
-            <a:picLocks noChangeAspect="1"/>
-          </p:cNvPicPr>
-          <p:nvPr/>
-        </p:nvPicPr>
-        <p:blipFill>
-          <a:blip r:embed="rId3"/>
-          <a:stretch>
-            <a:fillRect/>
-          </a:stretch>
-        </p:blipFill>
-        <p:spPr>
-          <a:xfrm>
-            <a:off x="666614" y="3276700"/>
-            <a:ext cx="5521536" cy="3874587"/>
-          </a:xfrm>
-          <a:prstGeom prst="rect">
-            <a:avLst/>
-          </a:prstGeom>
-        </p:spPr>
-      </p:pic>
+              <a:t>Ver.1.10  2026-07-22  Revisions for Integrated Design</a:t>
+            </a:r>
+          </a:p>
+          <a:p>
+            <a:r>
+              <a:rPr lang="en-US" altLang="ja-JP" sz="900" dirty="0">
+                <a:latin typeface="IBM Plex Sans JP" panose="020B0503050203000203" pitchFamily="50" charset="-128"/>
+                <a:ea typeface="IBM Plex Sans JP" panose="020B0503050203000203" pitchFamily="50" charset="-128"/>
+              </a:rPr>
+              <a:t>Ver.1.11  2026-08-08  Revisions to align with the Japanese version</a:t>
+            </a:r>
+          </a:p>
+        </p:txBody>
+      </p:sp>
     </p:spTree>
     <p:extLst>
       <p:ext uri="{BB962C8B-B14F-4D97-AF65-F5344CB8AC3E}">
-        <p14:creationId xmlns:p14="http://schemas.microsoft.com/office/powerpoint/2010/main" val="3659034256"/>
+        <p14:creationId xmlns:p14="http://schemas.microsoft.com/office/powerpoint/2010/main" val="3082964952"/>
       </p:ext>
     </p:extLst>
   </p:cSld>

</xml_diff>